<commit_message>
tuned parameters as best as I could
</commit_message>
<xml_diff>
--- a/Report_Presentation/Presentation.pptx
+++ b/Report_Presentation/Presentation.pptx
@@ -12,7 +12,9 @@
     <p:sldId id="263" r:id="rId6"/>
     <p:sldId id="264" r:id="rId7"/>
     <p:sldId id="265" r:id="rId8"/>
-    <p:sldId id="266" r:id="rId9"/>
+    <p:sldId id="268" r:id="rId9"/>
+    <p:sldId id="269" r:id="rId10"/>
+    <p:sldId id="266" r:id="rId11"/>
   </p:sldIdLst>
   <p:sldSz cx="12192000" cy="6858000"/>
   <p:notesSz cx="6858000" cy="9144000"/>
@@ -1274,7 +1276,7 @@
           <a:p>
             <a:fld id="{965D8904-8BFC-4615-A3B1-F40E2BC38C0D}" type="datetimeFigureOut">
               <a:rPr lang="en-US" smtClean="0"/>
-              <a:t>11/14/2025</a:t>
+              <a:t>11/26/2025</a:t>
             </a:fld>
             <a:endParaRPr lang="en-US"/>
           </a:p>
@@ -1598,7 +1600,7 @@
           <a:p>
             <a:fld id="{965D8904-8BFC-4615-A3B1-F40E2BC38C0D}" type="datetimeFigureOut">
               <a:rPr lang="en-US" smtClean="0"/>
-              <a:t>11/14/2025</a:t>
+              <a:t>11/26/2025</a:t>
             </a:fld>
             <a:endParaRPr lang="en-US"/>
           </a:p>
@@ -1796,7 +1798,7 @@
           <a:p>
             <a:fld id="{965D8904-8BFC-4615-A3B1-F40E2BC38C0D}" type="datetimeFigureOut">
               <a:rPr lang="en-US" smtClean="0"/>
-              <a:t>11/14/2025</a:t>
+              <a:t>11/26/2025</a:t>
             </a:fld>
             <a:endParaRPr lang="en-US"/>
           </a:p>
@@ -2004,7 +2006,7 @@
           <a:p>
             <a:fld id="{965D8904-8BFC-4615-A3B1-F40E2BC38C0D}" type="datetimeFigureOut">
               <a:rPr lang="en-US" smtClean="0"/>
-              <a:t>11/14/2025</a:t>
+              <a:t>11/26/2025</a:t>
             </a:fld>
             <a:endParaRPr lang="en-US"/>
           </a:p>
@@ -2289,7 +2291,7 @@
           <a:p>
             <a:fld id="{965D8904-8BFC-4615-A3B1-F40E2BC38C0D}" type="datetimeFigureOut">
               <a:rPr lang="en-US" smtClean="0"/>
-              <a:t>11/14/2025</a:t>
+              <a:t>11/26/2025</a:t>
             </a:fld>
             <a:endParaRPr lang="en-US"/>
           </a:p>
@@ -2590,7 +2592,7 @@
           <a:p>
             <a:fld id="{965D8904-8BFC-4615-A3B1-F40E2BC38C0D}" type="datetimeFigureOut">
               <a:rPr lang="en-US" smtClean="0"/>
-              <a:t>11/14/2025</a:t>
+              <a:t>11/26/2025</a:t>
             </a:fld>
             <a:endParaRPr lang="en-US"/>
           </a:p>
@@ -3005,7 +3007,7 @@
           <a:p>
             <a:fld id="{965D8904-8BFC-4615-A3B1-F40E2BC38C0D}" type="datetimeFigureOut">
               <a:rPr lang="en-US" smtClean="0"/>
-              <a:t>11/14/2025</a:t>
+              <a:t>11/26/2025</a:t>
             </a:fld>
             <a:endParaRPr lang="en-US"/>
           </a:p>
@@ -3270,7 +3272,7 @@
           <a:p>
             <a:fld id="{965D8904-8BFC-4615-A3B1-F40E2BC38C0D}" type="datetimeFigureOut">
               <a:rPr lang="en-US" smtClean="0"/>
-              <a:t>11/14/2025</a:t>
+              <a:t>11/26/2025</a:t>
             </a:fld>
             <a:endParaRPr lang="en-US"/>
           </a:p>
@@ -3682,7 +3684,7 @@
           <a:p>
             <a:fld id="{965D8904-8BFC-4615-A3B1-F40E2BC38C0D}" type="datetimeFigureOut">
               <a:rPr lang="en-US" smtClean="0"/>
-              <a:t>11/14/2025</a:t>
+              <a:t>11/26/2025</a:t>
             </a:fld>
             <a:endParaRPr lang="en-US"/>
           </a:p>
@@ -3823,7 +3825,7 @@
           <a:p>
             <a:fld id="{965D8904-8BFC-4615-A3B1-F40E2BC38C0D}" type="datetimeFigureOut">
               <a:rPr lang="en-US" smtClean="0"/>
-              <a:t>11/14/2025</a:t>
+              <a:t>11/26/2025</a:t>
             </a:fld>
             <a:endParaRPr lang="en-US"/>
           </a:p>
@@ -3936,7 +3938,7 @@
           <a:p>
             <a:fld id="{965D8904-8BFC-4615-A3B1-F40E2BC38C0D}" type="datetimeFigureOut">
               <a:rPr lang="en-US" smtClean="0"/>
-              <a:t>11/14/2025</a:t>
+              <a:t>11/26/2025</a:t>
             </a:fld>
             <a:endParaRPr lang="en-US"/>
           </a:p>
@@ -4247,7 +4249,7 @@
           <a:p>
             <a:fld id="{965D8904-8BFC-4615-A3B1-F40E2BC38C0D}" type="datetimeFigureOut">
               <a:rPr lang="en-US" smtClean="0"/>
-              <a:t>11/14/2025</a:t>
+              <a:t>11/26/2025</a:t>
             </a:fld>
             <a:endParaRPr lang="en-US"/>
           </a:p>
@@ -4488,7 +4490,7 @@
           <a:p>
             <a:fld id="{965D8904-8BFC-4615-A3B1-F40E2BC38C0D}" type="datetimeFigureOut">
               <a:rPr lang="en-US" smtClean="0"/>
-              <a:t>11/14/2025</a:t>
+              <a:t>11/26/2025</a:t>
             </a:fld>
             <a:endParaRPr lang="en-US"/>
           </a:p>
@@ -4977,6 +4979,94 @@
 </p:sld>
 </file>
 
+<file path=ppt/slides/slide10.xml><?xml version="1.0" encoding="utf-8"?>
+<p:sld xmlns:a="http://schemas.openxmlformats.org/drawingml/2006/main" xmlns:r="http://schemas.openxmlformats.org/officeDocument/2006/relationships" xmlns:p="http://schemas.openxmlformats.org/presentationml/2006/main">
+  <p:cSld>
+    <p:spTree>
+      <p:nvGrpSpPr>
+        <p:cNvPr id="1" name=""/>
+        <p:cNvGrpSpPr/>
+        <p:nvPr/>
+      </p:nvGrpSpPr>
+      <p:grpSpPr>
+        <a:xfrm>
+          <a:off x="0" y="0"/>
+          <a:ext cx="0" cy="0"/>
+          <a:chOff x="0" y="0"/>
+          <a:chExt cx="0" cy="0"/>
+        </a:xfrm>
+      </p:grpSpPr>
+      <p:sp>
+        <p:nvSpPr>
+          <p:cNvPr id="2" name="Title 1">
+            <a:extLst>
+              <a:ext uri="{FF2B5EF4-FFF2-40B4-BE49-F238E27FC236}">
+                <a16:creationId xmlns:a16="http://schemas.microsoft.com/office/drawing/2014/main" id="{A14716A4-8E0D-2487-2E14-87AB2BD94A19}"/>
+              </a:ext>
+            </a:extLst>
+          </p:cNvPr>
+          <p:cNvSpPr>
+            <a:spLocks noGrp="1"/>
+          </p:cNvSpPr>
+          <p:nvPr>
+            <p:ph type="ctrTitle"/>
+          </p:nvPr>
+        </p:nvSpPr>
+        <p:spPr/>
+        <p:txBody>
+          <a:bodyPr/>
+          <a:lstStyle/>
+          <a:p>
+            <a:r>
+              <a:rPr lang="en-GB" dirty="0"/>
+              <a:t>Thank You for Listening</a:t>
+            </a:r>
+            <a:endParaRPr lang="en-US" dirty="0"/>
+          </a:p>
+        </p:txBody>
+      </p:sp>
+      <p:sp>
+        <p:nvSpPr>
+          <p:cNvPr id="3" name="Subtitle 2">
+            <a:extLst>
+              <a:ext uri="{FF2B5EF4-FFF2-40B4-BE49-F238E27FC236}">
+                <a16:creationId xmlns:a16="http://schemas.microsoft.com/office/drawing/2014/main" id="{75FBCDBE-EC15-A448-9336-780D200BB5BF}"/>
+              </a:ext>
+            </a:extLst>
+          </p:cNvPr>
+          <p:cNvSpPr>
+            <a:spLocks noGrp="1"/>
+          </p:cNvSpPr>
+          <p:nvPr>
+            <p:ph type="subTitle" idx="1"/>
+          </p:nvPr>
+        </p:nvSpPr>
+        <p:spPr/>
+        <p:txBody>
+          <a:bodyPr/>
+          <a:lstStyle/>
+          <a:p>
+            <a:r>
+              <a:rPr lang="en-GB" dirty="0"/>
+              <a:t>Questions?</a:t>
+            </a:r>
+            <a:endParaRPr lang="en-US" dirty="0"/>
+          </a:p>
+        </p:txBody>
+      </p:sp>
+    </p:spTree>
+    <p:extLst>
+      <p:ext uri="{BB962C8B-B14F-4D97-AF65-F5344CB8AC3E}">
+        <p14:creationId xmlns:p14="http://schemas.microsoft.com/office/powerpoint/2010/main" val="770585874"/>
+      </p:ext>
+    </p:extLst>
+  </p:cSld>
+  <p:clrMapOvr>
+    <a:masterClrMapping/>
+  </p:clrMapOvr>
+</p:sld>
+</file>
+
 <file path=ppt/slides/slide2.xml><?xml version="1.0" encoding="utf-8"?>
 <p:sld xmlns:a="http://schemas.openxmlformats.org/drawingml/2006/main" xmlns:r="http://schemas.openxmlformats.org/officeDocument/2006/relationships" xmlns:p="http://schemas.openxmlformats.org/presentationml/2006/main">
   <p:cSld>
@@ -5291,7 +5381,9 @@
           </a:xfrm>
         </p:spPr>
         <p:txBody>
-          <a:bodyPr/>
+          <a:bodyPr>
+            <a:normAutofit lnSpcReduction="10000"/>
+          </a:bodyPr>
           <a:lstStyle/>
           <a:p>
             <a:pPr marL="0" indent="0">
@@ -5365,23 +5457,20 @@
           <a:p>
             <a:r>
               <a:rPr lang="en-GB" dirty="0"/>
-              <a:t>Automate inspection</a:t>
+              <a:t>Automate external inspection with free-floating platform</a:t>
             </a:r>
           </a:p>
           <a:p>
             <a:r>
               <a:rPr lang="en-GB" dirty="0"/>
-              <a:t>Free astronauts</a:t>
+              <a:t>Free astronaut time, reduce operation risk</a:t>
             </a:r>
           </a:p>
           <a:p>
             <a:r>
               <a:rPr lang="en-GB" dirty="0"/>
-              <a:t>Protect lives</a:t>
-            </a:r>
-          </a:p>
-          <a:p>
-            <a:endParaRPr lang="en-GB" dirty="0"/>
+              <a:t>Support next gen. commercial stations</a:t>
+            </a:r>
           </a:p>
           <a:p>
             <a:endParaRPr lang="en-US" dirty="0"/>
@@ -5719,7 +5808,7 @@
               <a:rPr lang="en-GB" b="1" dirty="0">
                 <a:latin typeface="Arial Nova" panose="020B0504020202020204" pitchFamily="34" charset="0"/>
               </a:rPr>
-              <a:t>Capability</a:t>
+              <a:t>Inspection Capability</a:t>
             </a:r>
             <a:endParaRPr lang="en-US" b="1" dirty="0">
               <a:latin typeface="Arial Nova" panose="020B0504020202020204" pitchFamily="34" charset="0"/>
@@ -5980,7 +6069,7 @@
         </p:blipFill>
         <p:spPr>
           <a:xfrm>
-            <a:off x="1477494" y="2276203"/>
+            <a:off x="1477494" y="1315626"/>
             <a:ext cx="1111898" cy="1111898"/>
           </a:xfrm>
           <a:prstGeom prst="rect">
@@ -6060,6 +6149,165 @@
           </a:prstGeom>
         </p:spPr>
       </p:pic>
+      <p:sp>
+        <p:nvSpPr>
+          <p:cNvPr id="6" name="TextBox 5">
+            <a:extLst>
+              <a:ext uri="{FF2B5EF4-FFF2-40B4-BE49-F238E27FC236}">
+                <a16:creationId xmlns:a16="http://schemas.microsoft.com/office/drawing/2014/main" id="{40A573B4-396C-19F7-3A98-DA394707CDCB}"/>
+              </a:ext>
+            </a:extLst>
+          </p:cNvPr>
+          <p:cNvSpPr txBox="1"/>
+          <p:nvPr/>
+        </p:nvSpPr>
+        <p:spPr>
+          <a:xfrm>
+            <a:off x="7725747" y="5860377"/>
+            <a:ext cx="4646645" cy="738664"/>
+          </a:xfrm>
+          <a:prstGeom prst="rect">
+            <a:avLst/>
+          </a:prstGeom>
+          <a:noFill/>
+        </p:spPr>
+        <p:txBody>
+          <a:bodyPr wrap="square" rtlCol="0">
+            <a:spAutoFit/>
+          </a:bodyPr>
+          <a:lstStyle/>
+          <a:p>
+            <a:r>
+              <a:rPr lang="en-US" sz="1400" dirty="0"/>
+              <a:t>B. Apodaca et al., "In-Orbit Space Structure Inspection Trajectory Generation," </a:t>
+            </a:r>
+            <a:r>
+              <a:rPr lang="en-US" sz="1400" i="1" dirty="0"/>
+              <a:t>IEEE RAL</a:t>
+            </a:r>
+            <a:r>
+              <a:rPr lang="en-US" sz="1400" dirty="0"/>
+              <a:t>, 2025, </a:t>
+            </a:r>
+            <a:r>
+              <a:rPr lang="en-US" sz="1400" dirty="0" err="1"/>
+              <a:t>doi</a:t>
+            </a:r>
+            <a:r>
+              <a:rPr lang="en-US" sz="1400" dirty="0"/>
+              <a:t>: 10.1109/LRA.2025.3583621. </a:t>
+            </a:r>
+          </a:p>
+        </p:txBody>
+      </p:sp>
+      <p:sp>
+        <p:nvSpPr>
+          <p:cNvPr id="8" name="Oval 7">
+            <a:extLst>
+              <a:ext uri="{FF2B5EF4-FFF2-40B4-BE49-F238E27FC236}">
+                <a16:creationId xmlns:a16="http://schemas.microsoft.com/office/drawing/2014/main" id="{58B0F343-B369-A61B-8D05-9C72E3D0B796}"/>
+              </a:ext>
+            </a:extLst>
+          </p:cNvPr>
+          <p:cNvSpPr/>
+          <p:nvPr/>
+        </p:nvSpPr>
+        <p:spPr>
+          <a:xfrm>
+            <a:off x="7619905" y="5949332"/>
+            <a:ext cx="139959" cy="139959"/>
+          </a:xfrm>
+          <a:prstGeom prst="ellipse">
+            <a:avLst/>
+          </a:prstGeom>
+          <a:solidFill>
+            <a:srgbClr val="EEB548"/>
+          </a:solidFill>
+          <a:ln>
+            <a:solidFill>
+              <a:schemeClr val="tx1"/>
+            </a:solidFill>
+          </a:ln>
+        </p:spPr>
+        <p:style>
+          <a:lnRef idx="2">
+            <a:schemeClr val="accent1">
+              <a:shade val="15000"/>
+            </a:schemeClr>
+          </a:lnRef>
+          <a:fillRef idx="1">
+            <a:schemeClr val="accent1"/>
+          </a:fillRef>
+          <a:effectRef idx="0">
+            <a:schemeClr val="accent1"/>
+          </a:effectRef>
+          <a:fontRef idx="minor">
+            <a:schemeClr val="lt1"/>
+          </a:fontRef>
+        </p:style>
+        <p:txBody>
+          <a:bodyPr rtlCol="0" anchor="ctr"/>
+          <a:lstStyle/>
+          <a:p>
+            <a:pPr algn="ctr"/>
+            <a:endParaRPr lang="en-US"/>
+          </a:p>
+        </p:txBody>
+      </p:sp>
+      <p:sp>
+        <p:nvSpPr>
+          <p:cNvPr id="9" name="Oval 8">
+            <a:extLst>
+              <a:ext uri="{FF2B5EF4-FFF2-40B4-BE49-F238E27FC236}">
+                <a16:creationId xmlns:a16="http://schemas.microsoft.com/office/drawing/2014/main" id="{E739AE15-950A-7AE1-E17F-EC814924414B}"/>
+              </a:ext>
+            </a:extLst>
+          </p:cNvPr>
+          <p:cNvSpPr/>
+          <p:nvPr/>
+        </p:nvSpPr>
+        <p:spPr>
+          <a:xfrm>
+            <a:off x="2544848" y="1801595"/>
+            <a:ext cx="139959" cy="139959"/>
+          </a:xfrm>
+          <a:prstGeom prst="ellipse">
+            <a:avLst/>
+          </a:prstGeom>
+          <a:solidFill>
+            <a:srgbClr val="EEB548"/>
+          </a:solidFill>
+          <a:ln>
+            <a:solidFill>
+              <a:schemeClr val="tx1"/>
+            </a:solidFill>
+          </a:ln>
+        </p:spPr>
+        <p:style>
+          <a:lnRef idx="2">
+            <a:schemeClr val="accent1">
+              <a:shade val="15000"/>
+            </a:schemeClr>
+          </a:lnRef>
+          <a:fillRef idx="1">
+            <a:schemeClr val="accent1"/>
+          </a:fillRef>
+          <a:effectRef idx="0">
+            <a:schemeClr val="accent1"/>
+          </a:effectRef>
+          <a:fontRef idx="minor">
+            <a:schemeClr val="lt1"/>
+          </a:fontRef>
+        </p:style>
+        <p:txBody>
+          <a:bodyPr rtlCol="0" anchor="ctr"/>
+          <a:lstStyle/>
+          <a:p>
+            <a:pPr algn="ctr"/>
+            <a:endParaRPr lang="en-US"/>
+          </a:p>
+        </p:txBody>
+      </p:sp>
     </p:spTree>
     <p:extLst>
       <p:ext uri="{BB962C8B-B14F-4D97-AF65-F5344CB8AC3E}">
@@ -6137,12 +6385,143 @@
             <p:ph idx="1"/>
           </p:nvPr>
         </p:nvSpPr>
-        <p:spPr/>
+        <p:spPr>
+          <a:xfrm>
+            <a:off x="6096000" y="1104231"/>
+            <a:ext cx="5863574" cy="5389165"/>
+          </a:xfrm>
+        </p:spPr>
         <p:txBody>
           <a:bodyPr/>
           <a:lstStyle/>
           <a:p>
-            <a:endParaRPr lang="en-US"/>
+            <a:r>
+              <a:rPr lang="en-GB" dirty="0">
+                <a:highlight>
+                  <a:srgbClr val="FF0000"/>
+                </a:highlight>
+              </a:rPr>
+              <a:t>X</a:t>
+            </a:r>
+            <a:r>
+              <a:rPr lang="en-GB" dirty="0"/>
+              <a:t>U CubeSat, nitrogen thrusters, </a:t>
+            </a:r>
+            <a:r>
+              <a:rPr lang="en-GB" dirty="0">
+                <a:highlight>
+                  <a:srgbClr val="FF0000"/>
+                </a:highlight>
+              </a:rPr>
+              <a:t>X</a:t>
+            </a:r>
+            <a:r>
+              <a:rPr lang="en-GB" dirty="0"/>
+              <a:t> sensor, 6 DOF</a:t>
+            </a:r>
+          </a:p>
+          <a:p>
+            <a:r>
+              <a:rPr lang="en-GB" dirty="0"/>
+              <a:t>Operates external from space station, launchable from airlock</a:t>
+            </a:r>
+          </a:p>
+          <a:p>
+            <a:r>
+              <a:rPr lang="en-GB" dirty="0"/>
+              <a:t>Algorithm &amp; autonomy stack:</a:t>
+            </a:r>
+          </a:p>
+          <a:p>
+            <a:pPr lvl="1"/>
+            <a:r>
+              <a:rPr lang="en-GB" dirty="0"/>
+              <a:t>Model processing</a:t>
+            </a:r>
+          </a:p>
+          <a:p>
+            <a:pPr lvl="1"/>
+            <a:r>
+              <a:rPr lang="en-GB" dirty="0"/>
+              <a:t>Viewpoint generation &amp; clustering</a:t>
+            </a:r>
+          </a:p>
+          <a:p>
+            <a:pPr lvl="1"/>
+            <a:r>
+              <a:rPr lang="en-GB" dirty="0"/>
+              <a:t>Path generation</a:t>
+            </a:r>
+          </a:p>
+          <a:p>
+            <a:pPr lvl="1"/>
+            <a:r>
+              <a:rPr lang="en-GB" dirty="0"/>
+              <a:t>Trajectory generation</a:t>
+            </a:r>
+          </a:p>
+          <a:p>
+            <a:pPr lvl="1"/>
+            <a:r>
+              <a:rPr lang="en-GB" dirty="0"/>
+              <a:t>Path execution &amp; control</a:t>
+            </a:r>
+            <a:endParaRPr lang="en-US" dirty="0"/>
+          </a:p>
+        </p:txBody>
+      </p:sp>
+      <p:sp>
+        <p:nvSpPr>
+          <p:cNvPr id="4" name="Rectangle 3">
+            <a:extLst>
+              <a:ext uri="{FF2B5EF4-FFF2-40B4-BE49-F238E27FC236}">
+                <a16:creationId xmlns:a16="http://schemas.microsoft.com/office/drawing/2014/main" id="{BCD413E8-1AE9-5D46-F4A9-BC3BD0BE968A}"/>
+              </a:ext>
+            </a:extLst>
+          </p:cNvPr>
+          <p:cNvSpPr/>
+          <p:nvPr/>
+        </p:nvSpPr>
+        <p:spPr>
+          <a:xfrm>
+            <a:off x="171450" y="1104230"/>
+            <a:ext cx="5657850" cy="5389165"/>
+          </a:xfrm>
+          <a:prstGeom prst="rect">
+            <a:avLst/>
+          </a:prstGeom>
+          <a:solidFill>
+            <a:schemeClr val="bg2">
+              <a:lumMod val="75000"/>
+            </a:schemeClr>
+          </a:solidFill>
+        </p:spPr>
+        <p:style>
+          <a:lnRef idx="2">
+            <a:schemeClr val="accent1">
+              <a:shade val="15000"/>
+            </a:schemeClr>
+          </a:lnRef>
+          <a:fillRef idx="1">
+            <a:schemeClr val="accent1"/>
+          </a:fillRef>
+          <a:effectRef idx="0">
+            <a:schemeClr val="accent1"/>
+          </a:effectRef>
+          <a:fontRef idx="minor">
+            <a:schemeClr val="lt1"/>
+          </a:fontRef>
+        </p:style>
+        <p:txBody>
+          <a:bodyPr rtlCol="0" anchor="ctr"/>
+          <a:lstStyle/>
+          <a:p>
+            <a:pPr algn="ctr"/>
+            <a:r>
+              <a:rPr lang="en-GB" dirty="0"/>
+              <a:t>Picture of Satellite Goes Here</a:t>
+            </a:r>
+            <a:endParaRPr lang="en-US" dirty="0"/>
           </a:p>
         </p:txBody>
       </p:sp>
@@ -6199,37 +6578,123 @@
           <a:p>
             <a:r>
               <a:rPr lang="en-GB" dirty="0"/>
-              <a:t>Technical Contributions</a:t>
+              <a:t>Technical Contributions: Planning</a:t>
             </a:r>
             <a:endParaRPr lang="en-US" dirty="0"/>
           </a:p>
         </p:txBody>
       </p:sp>
-      <p:sp>
-        <p:nvSpPr>
-          <p:cNvPr id="3" name="Content Placeholder 2">
-            <a:extLst>
-              <a:ext uri="{FF2B5EF4-FFF2-40B4-BE49-F238E27FC236}">
-                <a16:creationId xmlns:a16="http://schemas.microsoft.com/office/drawing/2014/main" id="{5A162E20-C12D-9EAE-E552-DDE45887806A}"/>
-              </a:ext>
-            </a:extLst>
-          </p:cNvPr>
-          <p:cNvSpPr>
-            <a:spLocks noGrp="1"/>
-          </p:cNvSpPr>
-          <p:nvPr>
-            <p:ph idx="1"/>
-          </p:nvPr>
-        </p:nvSpPr>
-        <p:spPr/>
-        <p:txBody>
-          <a:bodyPr/>
-          <a:lstStyle/>
-          <a:p>
-            <a:endParaRPr lang="en-US"/>
-          </a:p>
-        </p:txBody>
-      </p:sp>
+      <p:pic>
+        <p:nvPicPr>
+          <p:cNvPr id="5" name="Picture 4" descr="A satellite with multiple antennas&#10;&#10;AI-generated content may be incorrect.">
+            <a:extLst>
+              <a:ext uri="{FF2B5EF4-FFF2-40B4-BE49-F238E27FC236}">
+                <a16:creationId xmlns:a16="http://schemas.microsoft.com/office/drawing/2014/main" id="{C93896F6-67C9-7C09-C2F2-E149BAD47CD3}"/>
+              </a:ext>
+            </a:extLst>
+          </p:cNvPr>
+          <p:cNvPicPr>
+            <a:picLocks noChangeAspect="1"/>
+          </p:cNvPicPr>
+          <p:nvPr/>
+        </p:nvPicPr>
+        <p:blipFill>
+          <a:blip r:embed="rId2">
+            <a:extLst>
+              <a:ext uri="{28A0092B-C50C-407E-A947-70E740481C1C}">
+                <a14:useLocalDpi xmlns:a14="http://schemas.microsoft.com/office/drawing/2010/main" val="0"/>
+              </a:ext>
+            </a:extLst>
+          </a:blip>
+          <a:srcRect l="29599" t="23810" r="24521" b="9251"/>
+          <a:stretch>
+            <a:fillRect/>
+          </a:stretch>
+        </p:blipFill>
+        <p:spPr>
+          <a:xfrm>
+            <a:off x="494522" y="1207019"/>
+            <a:ext cx="2854288" cy="2664725"/>
+          </a:xfrm>
+          <a:prstGeom prst="rect">
+            <a:avLst/>
+          </a:prstGeom>
+        </p:spPr>
+      </p:pic>
+      <p:pic>
+        <p:nvPicPr>
+          <p:cNvPr id="7" name="Picture 6" descr="A close-up of a satellite&#10;&#10;AI-generated content may be incorrect.">
+            <a:extLst>
+              <a:ext uri="{FF2B5EF4-FFF2-40B4-BE49-F238E27FC236}">
+                <a16:creationId xmlns:a16="http://schemas.microsoft.com/office/drawing/2014/main" id="{20400C12-6997-76AA-5519-1FC4BE1FE044}"/>
+              </a:ext>
+            </a:extLst>
+          </p:cNvPr>
+          <p:cNvPicPr>
+            <a:picLocks noChangeAspect="1"/>
+          </p:cNvPicPr>
+          <p:nvPr/>
+        </p:nvPicPr>
+        <p:blipFill>
+          <a:blip r:embed="rId3">
+            <a:extLst>
+              <a:ext uri="{28A0092B-C50C-407E-A947-70E740481C1C}">
+                <a14:useLocalDpi xmlns:a14="http://schemas.microsoft.com/office/drawing/2010/main" val="0"/>
+              </a:ext>
+            </a:extLst>
+          </a:blip>
+          <a:srcRect l="31442" t="27211" r="28194" b="13197"/>
+          <a:stretch>
+            <a:fillRect/>
+          </a:stretch>
+        </p:blipFill>
+        <p:spPr>
+          <a:xfrm>
+            <a:off x="4249655" y="1207019"/>
+            <a:ext cx="2822904" cy="2664725"/>
+          </a:xfrm>
+          <a:prstGeom prst="rect">
+            <a:avLst/>
+          </a:prstGeom>
+        </p:spPr>
+      </p:pic>
+      <p:pic>
+        <p:nvPicPr>
+          <p:cNvPr id="9" name="Picture 8" descr="A computer generated image of a map&#10;&#10;AI-generated content may be incorrect.">
+            <a:extLst>
+              <a:ext uri="{FF2B5EF4-FFF2-40B4-BE49-F238E27FC236}">
+                <a16:creationId xmlns:a16="http://schemas.microsoft.com/office/drawing/2014/main" id="{21B8F66B-5B02-C3B5-31E4-9B1D7BB5849A}"/>
+              </a:ext>
+            </a:extLst>
+          </p:cNvPr>
+          <p:cNvPicPr>
+            <a:picLocks noChangeAspect="1"/>
+          </p:cNvPicPr>
+          <p:nvPr/>
+        </p:nvPicPr>
+        <p:blipFill>
+          <a:blip r:embed="rId4">
+            <a:extLst>
+              <a:ext uri="{28A0092B-C50C-407E-A947-70E740481C1C}">
+                <a14:useLocalDpi xmlns:a14="http://schemas.microsoft.com/office/drawing/2010/main" val="0"/>
+              </a:ext>
+            </a:extLst>
+          </a:blip>
+          <a:srcRect l="22525" t="8271" r="20843" b="22284"/>
+          <a:stretch>
+            <a:fillRect/>
+          </a:stretch>
+        </p:blipFill>
+        <p:spPr>
+          <a:xfrm>
+            <a:off x="7585790" y="1207019"/>
+            <a:ext cx="4256579" cy="2664725"/>
+          </a:xfrm>
+          <a:prstGeom prst="rect">
+            <a:avLst/>
+          </a:prstGeom>
+        </p:spPr>
+      </p:pic>
     </p:spTree>
     <p:extLst>
       <p:ext uri="{BB962C8B-B14F-4D97-AF65-F5344CB8AC3E}">
@@ -6248,7 +6713,13 @@
   <p:cSld>
     <p:spTree>
       <p:nvGrpSpPr>
-        <p:cNvPr id="1" name=""/>
+        <p:cNvPr id="1" name="">
+          <a:extLst>
+            <a:ext uri="{FF2B5EF4-FFF2-40B4-BE49-F238E27FC236}">
+              <a16:creationId xmlns:a16="http://schemas.microsoft.com/office/drawing/2014/main" id="{959867F4-6C7D-A12D-AA74-A2369AC965E0}"/>
+            </a:ext>
+          </a:extLst>
+        </p:cNvPr>
         <p:cNvGrpSpPr/>
         <p:nvPr/>
       </p:nvGrpSpPr>
@@ -6265,15 +6736,15 @@
           <p:cNvPr id="2" name="Title 1">
             <a:extLst>
               <a:ext uri="{FF2B5EF4-FFF2-40B4-BE49-F238E27FC236}">
-                <a16:creationId xmlns:a16="http://schemas.microsoft.com/office/drawing/2014/main" id="{A14716A4-8E0D-2487-2E14-87AB2BD94A19}"/>
-              </a:ext>
-            </a:extLst>
-          </p:cNvPr>
-          <p:cNvSpPr>
-            <a:spLocks noGrp="1"/>
-          </p:cNvSpPr>
-          <p:nvPr>
-            <p:ph type="ctrTitle"/>
+                <a16:creationId xmlns:a16="http://schemas.microsoft.com/office/drawing/2014/main" id="{036D4C97-5E24-72A9-B2CA-BBD775C54C55}"/>
+              </a:ext>
+            </a:extLst>
+          </p:cNvPr>
+          <p:cNvSpPr>
+            <a:spLocks noGrp="1"/>
+          </p:cNvSpPr>
+          <p:nvPr>
+            <p:ph type="title"/>
           </p:nvPr>
         </p:nvSpPr>
         <p:spPr/>
@@ -6283,7 +6754,7 @@
           <a:p>
             <a:r>
               <a:rPr lang="en-GB" dirty="0"/>
-              <a:t>Thank You for Listening</a:t>
+              <a:t>Technical Contributions: Control</a:t>
             </a:r>
             <a:endParaRPr lang="en-US" dirty="0"/>
           </a:p>
@@ -6291,28 +6762,92 @@
       </p:sp>
       <p:sp>
         <p:nvSpPr>
-          <p:cNvPr id="3" name="Subtitle 2">
-            <a:extLst>
-              <a:ext uri="{FF2B5EF4-FFF2-40B4-BE49-F238E27FC236}">
-                <a16:creationId xmlns:a16="http://schemas.microsoft.com/office/drawing/2014/main" id="{75FBCDBE-EC15-A448-9336-780D200BB5BF}"/>
-              </a:ext>
-            </a:extLst>
-          </p:cNvPr>
-          <p:cNvSpPr>
-            <a:spLocks noGrp="1"/>
-          </p:cNvSpPr>
-          <p:nvPr>
-            <p:ph type="subTitle" idx="1"/>
-          </p:nvPr>
-        </p:nvSpPr>
-        <p:spPr/>
+          <p:cNvPr id="3" name="Content Placeholder 2">
+            <a:extLst>
+              <a:ext uri="{FF2B5EF4-FFF2-40B4-BE49-F238E27FC236}">
+                <a16:creationId xmlns:a16="http://schemas.microsoft.com/office/drawing/2014/main" id="{2880A734-FECB-AF9C-2070-4F1B72CBE8F9}"/>
+              </a:ext>
+            </a:extLst>
+          </p:cNvPr>
+          <p:cNvSpPr>
+            <a:spLocks noGrp="1"/>
+          </p:cNvSpPr>
+          <p:nvPr>
+            <p:ph idx="1"/>
+          </p:nvPr>
+        </p:nvSpPr>
+        <p:spPr>
+          <a:xfrm>
+            <a:off x="6096000" y="1104231"/>
+            <a:ext cx="5863574" cy="5389165"/>
+          </a:xfrm>
+        </p:spPr>
         <p:txBody>
           <a:bodyPr/>
           <a:lstStyle/>
           <a:p>
+            <a:endParaRPr lang="en-US" dirty="0"/>
+          </a:p>
+        </p:txBody>
+      </p:sp>
+      <p:sp>
+        <p:nvSpPr>
+          <p:cNvPr id="4" name="Rectangle 3">
+            <a:extLst>
+              <a:ext uri="{FF2B5EF4-FFF2-40B4-BE49-F238E27FC236}">
+                <a16:creationId xmlns:a16="http://schemas.microsoft.com/office/drawing/2014/main" id="{3CC7DEFF-A916-0B04-3379-AAC79735E7AA}"/>
+              </a:ext>
+            </a:extLst>
+          </p:cNvPr>
+          <p:cNvSpPr/>
+          <p:nvPr/>
+        </p:nvSpPr>
+        <p:spPr>
+          <a:xfrm>
+            <a:off x="171450" y="1104230"/>
+            <a:ext cx="5657850" cy="5389165"/>
+          </a:xfrm>
+          <a:prstGeom prst="rect">
+            <a:avLst/>
+          </a:prstGeom>
+          <a:solidFill>
+            <a:schemeClr val="bg2">
+              <a:lumMod val="75000"/>
+            </a:schemeClr>
+          </a:solidFill>
+        </p:spPr>
+        <p:style>
+          <a:lnRef idx="2">
+            <a:schemeClr val="accent1">
+              <a:shade val="15000"/>
+            </a:schemeClr>
+          </a:lnRef>
+          <a:fillRef idx="1">
+            <a:schemeClr val="accent1"/>
+          </a:fillRef>
+          <a:effectRef idx="0">
+            <a:schemeClr val="accent1"/>
+          </a:effectRef>
+          <a:fontRef idx="minor">
+            <a:schemeClr val="lt1"/>
+          </a:fontRef>
+        </p:style>
+        <p:txBody>
+          <a:bodyPr rtlCol="0" anchor="ctr"/>
+          <a:lstStyle/>
+          <a:p>
+            <a:pPr algn="ctr"/>
             <a:r>
               <a:rPr lang="en-GB" dirty="0"/>
-              <a:t>Questions?</a:t>
+              <a:t>Video of satellite </a:t>
+            </a:r>
+            <a:r>
+              <a:rPr lang="en-GB" dirty="0" err="1"/>
+              <a:t>maneuvering</a:t>
+            </a:r>
+            <a:r>
+              <a:rPr lang="en-GB" dirty="0"/>
+              <a:t> goes here</a:t>
             </a:r>
             <a:endParaRPr lang="en-US" dirty="0"/>
           </a:p>
@@ -6321,7 +6856,145 @@
     </p:spTree>
     <p:extLst>
       <p:ext uri="{BB962C8B-B14F-4D97-AF65-F5344CB8AC3E}">
-        <p14:creationId xmlns:p14="http://schemas.microsoft.com/office/powerpoint/2010/main" val="770585874"/>
+        <p14:creationId xmlns:p14="http://schemas.microsoft.com/office/powerpoint/2010/main" val="1465247006"/>
+      </p:ext>
+    </p:extLst>
+  </p:cSld>
+  <p:clrMapOvr>
+    <a:masterClrMapping/>
+  </p:clrMapOvr>
+</p:sld>
+</file>
+
+<file path=ppt/slides/slide9.xml><?xml version="1.0" encoding="utf-8"?>
+<p:sld xmlns:a="http://schemas.openxmlformats.org/drawingml/2006/main" xmlns:r="http://schemas.openxmlformats.org/officeDocument/2006/relationships" xmlns:p="http://schemas.openxmlformats.org/presentationml/2006/main">
+  <p:cSld>
+    <p:spTree>
+      <p:nvGrpSpPr>
+        <p:cNvPr id="1" name="">
+          <a:extLst>
+            <a:ext uri="{FF2B5EF4-FFF2-40B4-BE49-F238E27FC236}">
+              <a16:creationId xmlns:a16="http://schemas.microsoft.com/office/drawing/2014/main" id="{3F540331-03E6-ED67-8D75-C2E987422C2C}"/>
+            </a:ext>
+          </a:extLst>
+        </p:cNvPr>
+        <p:cNvGrpSpPr/>
+        <p:nvPr/>
+      </p:nvGrpSpPr>
+      <p:grpSpPr>
+        <a:xfrm>
+          <a:off x="0" y="0"/>
+          <a:ext cx="0" cy="0"/>
+          <a:chOff x="0" y="0"/>
+          <a:chExt cx="0" cy="0"/>
+        </a:xfrm>
+      </p:grpSpPr>
+      <p:sp>
+        <p:nvSpPr>
+          <p:cNvPr id="2" name="Title 1">
+            <a:extLst>
+              <a:ext uri="{FF2B5EF4-FFF2-40B4-BE49-F238E27FC236}">
+                <a16:creationId xmlns:a16="http://schemas.microsoft.com/office/drawing/2014/main" id="{F0C75466-27F4-BEF6-9F67-0DD3857101F9}"/>
+              </a:ext>
+            </a:extLst>
+          </p:cNvPr>
+          <p:cNvSpPr>
+            <a:spLocks noGrp="1"/>
+          </p:cNvSpPr>
+          <p:nvPr>
+            <p:ph type="title"/>
+          </p:nvPr>
+        </p:nvSpPr>
+        <p:spPr/>
+        <p:txBody>
+          <a:bodyPr/>
+          <a:lstStyle/>
+          <a:p>
+            <a:r>
+              <a:rPr lang="en-GB" dirty="0"/>
+              <a:t>Next Steps: Current Risks, Limitations)</a:t>
+            </a:r>
+            <a:endParaRPr lang="en-US" dirty="0"/>
+          </a:p>
+        </p:txBody>
+      </p:sp>
+      <p:sp>
+        <p:nvSpPr>
+          <p:cNvPr id="3" name="Content Placeholder 2">
+            <a:extLst>
+              <a:ext uri="{FF2B5EF4-FFF2-40B4-BE49-F238E27FC236}">
+                <a16:creationId xmlns:a16="http://schemas.microsoft.com/office/drawing/2014/main" id="{6560126E-897A-7620-5607-AE3292E64915}"/>
+              </a:ext>
+            </a:extLst>
+          </p:cNvPr>
+          <p:cNvSpPr>
+            <a:spLocks noGrp="1"/>
+          </p:cNvSpPr>
+          <p:nvPr>
+            <p:ph idx="1"/>
+          </p:nvPr>
+        </p:nvSpPr>
+        <p:spPr>
+          <a:xfrm>
+            <a:off x="177282" y="1104231"/>
+            <a:ext cx="11782292" cy="5389165"/>
+          </a:xfrm>
+        </p:spPr>
+        <p:txBody>
+          <a:bodyPr/>
+          <a:lstStyle/>
+          <a:p>
+            <a:r>
+              <a:rPr lang="en-GB" dirty="0"/>
+              <a:t>Refine stack to eliminate risks, failure cases, limitations:</a:t>
+            </a:r>
+          </a:p>
+          <a:p>
+            <a:pPr lvl="1"/>
+            <a:r>
+              <a:rPr lang="en-GB" dirty="0"/>
+              <a:t>Refine collision detection, some manual checks still required</a:t>
+            </a:r>
+          </a:p>
+          <a:p>
+            <a:pPr lvl="1"/>
+            <a:r>
+              <a:rPr lang="en-GB" dirty="0"/>
+              <a:t>Implement mechanisms </a:t>
+            </a:r>
+            <a:r>
+              <a:rPr lang="en-GB"/>
+              <a:t>to automatically tune </a:t>
+            </a:r>
+            <a:r>
+              <a:rPr lang="en-GB" dirty="0"/>
+              <a:t>pipeline parameters to optimize coverage e.g., clustering, model pre-processing</a:t>
+            </a:r>
+          </a:p>
+          <a:p>
+            <a:pPr lvl="1"/>
+            <a:r>
+              <a:rPr lang="en-GB" dirty="0"/>
+              <a:t>Move from free-floating dynamics to Clohessy-Wiltshire in optimization step</a:t>
+            </a:r>
+          </a:p>
+          <a:p>
+            <a:pPr lvl="1"/>
+            <a:endParaRPr lang="en-GB" dirty="0"/>
+          </a:p>
+          <a:p>
+            <a:endParaRPr lang="en-GB" dirty="0"/>
+          </a:p>
+          <a:p>
+            <a:pPr lvl="1"/>
+            <a:endParaRPr lang="en-US" dirty="0"/>
+          </a:p>
+        </p:txBody>
+      </p:sp>
+    </p:spTree>
+    <p:extLst>
+      <p:ext uri="{BB962C8B-B14F-4D97-AF65-F5344CB8AC3E}">
+        <p14:creationId xmlns:p14="http://schemas.microsoft.com/office/powerpoint/2010/main" val="3963628732"/>
       </p:ext>
     </p:extLst>
   </p:cSld>

</xml_diff>